<commit_message>
feat: add lesson presentation for missing numbers topic
</commit_message>
<xml_diff>
--- a/Finding_Missing_Numbers_Lesson/Missing_Numbers_Presentation.pptx
+++ b/Finding_Missing_Numbers_Lesson/Missing_Numbers_Presentation.pptx
@@ -5,15 +5,16 @@
     <p:sldMasterId id="2147483648" r:id="rId1"/>
   </p:sldMasterIdLst>
   <p:sldIdLst>
-    <p:sldId id="256" r:id="rId7"/>
-    <p:sldId id="257" r:id="rId8"/>
-    <p:sldId id="258" r:id="rId9"/>
-    <p:sldId id="259" r:id="rId10"/>
-    <p:sldId id="260" r:id="rId11"/>
-    <p:sldId id="261" r:id="rId12"/>
-    <p:sldId id="262" r:id="rId13"/>
+    <p:sldId id="256" r:id="rId2"/>
+    <p:sldId id="257" r:id="rId3"/>
+    <p:sldId id="263" r:id="rId4"/>
+    <p:sldId id="258" r:id="rId5"/>
+    <p:sldId id="259" r:id="rId6"/>
+    <p:sldId id="260" r:id="rId7"/>
+    <p:sldId id="261" r:id="rId8"/>
+    <p:sldId id="262" r:id="rId9"/>
   </p:sldIdLst>
-  <p:sldSz cx="9144000" cy="5143500" type="screen4x3"/>
+  <p:sldSz cx="9144000" cy="5143500" type="screen16x9"/>
   <p:notesSz cx="6858000" cy="9144000"/>
   <p:defaultTextStyle>
     <a:defPPr>
@@ -110,6 +111,22 @@
       </a:defRPr>
     </a:lvl9pPr>
   </p:defaultTextStyle>
+  <p:extLst>
+    <p:ext uri="{EFAFB233-063F-42B5-8137-9DF3F51BA10A}">
+      <p15:sldGuideLst xmlns:p15="http://schemas.microsoft.com/office/powerpoint/2012/main">
+        <p15:guide id="1" orient="horz" pos="2160">
+          <p15:clr>
+            <a:srgbClr val="A4A3A4"/>
+          </p15:clr>
+        </p15:guide>
+        <p15:guide id="2" pos="2880">
+          <p15:clr>
+            <a:srgbClr val="A4A3A4"/>
+          </p15:clr>
+        </p15:guide>
+      </p15:sldGuideLst>
+    </p:ext>
+  </p:extLst>
 </p:presentation>
 </file>
 
@@ -151,10 +168,9 @@
           <a:lstStyle/>
           <a:p>
             <a:r>
-              <a:rPr lang="en-US" smtClean="0"/>
+              <a:rPr lang="en-US"/>
               <a:t>Click to edit Master title style</a:t>
             </a:r>
-            <a:endParaRPr lang="en-US"/>
           </a:p>
         </p:txBody>
       </p:sp>
@@ -270,10 +286,9 @@
           </a:lstStyle>
           <a:p>
             <a:r>
-              <a:rPr lang="en-US" smtClean="0"/>
+              <a:rPr lang="en-US"/>
               <a:t>Click to edit Master subtitle style</a:t>
             </a:r>
-            <a:endParaRPr lang="en-US"/>
           </a:p>
         </p:txBody>
       </p:sp>
@@ -294,7 +309,7 @@
           <a:p>
             <a:fld id="{5BCAD085-E8A6-8845-BD4E-CB4CCA059FC4}" type="datetimeFigureOut">
               <a:rPr lang="en-US" smtClean="0"/>
-              <a:t>1/27/13</a:t>
+              <a:t>5/14/2026</a:t>
             </a:fld>
             <a:endParaRPr lang="en-US"/>
           </a:p>
@@ -388,10 +403,9 @@
           <a:lstStyle/>
           <a:p>
             <a:r>
-              <a:rPr lang="en-US" smtClean="0"/>
+              <a:rPr lang="en-US"/>
               <a:t>Click to edit Master title style</a:t>
             </a:r>
-            <a:endParaRPr lang="en-US"/>
           </a:p>
         </p:txBody>
       </p:sp>
@@ -412,38 +426,37 @@
           <a:p>
             <a:pPr lvl="0"/>
             <a:r>
-              <a:rPr lang="en-US" smtClean="0"/>
+              <a:rPr lang="en-US"/>
               <a:t>Click to edit Master text styles</a:t>
             </a:r>
           </a:p>
           <a:p>
             <a:pPr lvl="1"/>
             <a:r>
-              <a:rPr lang="en-US" smtClean="0"/>
+              <a:rPr lang="en-US"/>
               <a:t>Second level</a:t>
             </a:r>
           </a:p>
           <a:p>
             <a:pPr lvl="2"/>
             <a:r>
-              <a:rPr lang="en-US" smtClean="0"/>
+              <a:rPr lang="en-US"/>
               <a:t>Third level</a:t>
             </a:r>
           </a:p>
           <a:p>
             <a:pPr lvl="3"/>
             <a:r>
-              <a:rPr lang="en-US" smtClean="0"/>
+              <a:rPr lang="en-US"/>
               <a:t>Fourth level</a:t>
             </a:r>
           </a:p>
           <a:p>
             <a:pPr lvl="4"/>
             <a:r>
-              <a:rPr lang="en-US" smtClean="0"/>
+              <a:rPr lang="en-US"/>
               <a:t>Fifth level</a:t>
             </a:r>
-            <a:endParaRPr lang="en-US"/>
           </a:p>
         </p:txBody>
       </p:sp>
@@ -464,7 +477,7 @@
           <a:p>
             <a:fld id="{5BCAD085-E8A6-8845-BD4E-CB4CCA059FC4}" type="datetimeFigureOut">
               <a:rPr lang="en-US" smtClean="0"/>
-              <a:t>1/27/13</a:t>
+              <a:t>5/14/2026</a:t>
             </a:fld>
             <a:endParaRPr lang="en-US"/>
           </a:p>
@@ -563,10 +576,9 @@
           <a:lstStyle/>
           <a:p>
             <a:r>
-              <a:rPr lang="en-US" smtClean="0"/>
+              <a:rPr lang="en-US"/>
               <a:t>Click to edit Master title style</a:t>
             </a:r>
-            <a:endParaRPr lang="en-US"/>
           </a:p>
         </p:txBody>
       </p:sp>
@@ -592,38 +604,37 @@
           <a:p>
             <a:pPr lvl="0"/>
             <a:r>
-              <a:rPr lang="en-US" smtClean="0"/>
+              <a:rPr lang="en-US"/>
               <a:t>Click to edit Master text styles</a:t>
             </a:r>
           </a:p>
           <a:p>
             <a:pPr lvl="1"/>
             <a:r>
-              <a:rPr lang="en-US" smtClean="0"/>
+              <a:rPr lang="en-US"/>
               <a:t>Second level</a:t>
             </a:r>
           </a:p>
           <a:p>
             <a:pPr lvl="2"/>
             <a:r>
-              <a:rPr lang="en-US" smtClean="0"/>
+              <a:rPr lang="en-US"/>
               <a:t>Third level</a:t>
             </a:r>
           </a:p>
           <a:p>
             <a:pPr lvl="3"/>
             <a:r>
-              <a:rPr lang="en-US" smtClean="0"/>
+              <a:rPr lang="en-US"/>
               <a:t>Fourth level</a:t>
             </a:r>
           </a:p>
           <a:p>
             <a:pPr lvl="4"/>
             <a:r>
-              <a:rPr lang="en-US" smtClean="0"/>
+              <a:rPr lang="en-US"/>
               <a:t>Fifth level</a:t>
             </a:r>
-            <a:endParaRPr lang="en-US"/>
           </a:p>
         </p:txBody>
       </p:sp>
@@ -644,7 +655,7 @@
           <a:p>
             <a:fld id="{5BCAD085-E8A6-8845-BD4E-CB4CCA059FC4}" type="datetimeFigureOut">
               <a:rPr lang="en-US" smtClean="0"/>
-              <a:t>1/27/13</a:t>
+              <a:t>5/14/2026</a:t>
             </a:fld>
             <a:endParaRPr lang="en-US"/>
           </a:p>
@@ -738,10 +749,9 @@
           <a:lstStyle/>
           <a:p>
             <a:r>
-              <a:rPr lang="en-US" smtClean="0"/>
+              <a:rPr lang="en-US"/>
               <a:t>Click to edit Master title style</a:t>
             </a:r>
-            <a:endParaRPr lang="en-US"/>
           </a:p>
         </p:txBody>
       </p:sp>
@@ -762,38 +772,37 @@
           <a:p>
             <a:pPr lvl="0"/>
             <a:r>
-              <a:rPr lang="en-US" smtClean="0"/>
+              <a:rPr lang="en-US"/>
               <a:t>Click to edit Master text styles</a:t>
             </a:r>
           </a:p>
           <a:p>
             <a:pPr lvl="1"/>
             <a:r>
-              <a:rPr lang="en-US" smtClean="0"/>
+              <a:rPr lang="en-US"/>
               <a:t>Second level</a:t>
             </a:r>
           </a:p>
           <a:p>
             <a:pPr lvl="2"/>
             <a:r>
-              <a:rPr lang="en-US" smtClean="0"/>
+              <a:rPr lang="en-US"/>
               <a:t>Third level</a:t>
             </a:r>
           </a:p>
           <a:p>
             <a:pPr lvl="3"/>
             <a:r>
-              <a:rPr lang="en-US" smtClean="0"/>
+              <a:rPr lang="en-US"/>
               <a:t>Fourth level</a:t>
             </a:r>
           </a:p>
           <a:p>
             <a:pPr lvl="4"/>
             <a:r>
-              <a:rPr lang="en-US" smtClean="0"/>
+              <a:rPr lang="en-US"/>
               <a:t>Fifth level</a:t>
             </a:r>
-            <a:endParaRPr lang="en-US"/>
           </a:p>
         </p:txBody>
       </p:sp>
@@ -814,7 +823,7 @@
           <a:p>
             <a:fld id="{5BCAD085-E8A6-8845-BD4E-CB4CCA059FC4}" type="datetimeFigureOut">
               <a:rPr lang="en-US" smtClean="0"/>
-              <a:t>1/27/13</a:t>
+              <a:t>5/14/2026</a:t>
             </a:fld>
             <a:endParaRPr lang="en-US"/>
           </a:p>
@@ -917,10 +926,9 @@
           </a:lstStyle>
           <a:p>
             <a:r>
-              <a:rPr lang="en-US" smtClean="0"/>
+              <a:rPr lang="en-US"/>
               <a:t>Click to edit Master title style</a:t>
             </a:r>
-            <a:endParaRPr lang="en-US"/>
           </a:p>
         </p:txBody>
       </p:sp>
@@ -1037,7 +1045,7 @@
           <a:p>
             <a:pPr lvl="0"/>
             <a:r>
-              <a:rPr lang="en-US" smtClean="0"/>
+              <a:rPr lang="en-US"/>
               <a:t>Click to edit Master text styles</a:t>
             </a:r>
           </a:p>
@@ -1060,7 +1068,7 @@
           <a:p>
             <a:fld id="{5BCAD085-E8A6-8845-BD4E-CB4CCA059FC4}" type="datetimeFigureOut">
               <a:rPr lang="en-US" smtClean="0"/>
-              <a:t>1/27/13</a:t>
+              <a:t>5/14/2026</a:t>
             </a:fld>
             <a:endParaRPr lang="en-US"/>
           </a:p>
@@ -1154,10 +1162,9 @@
           <a:lstStyle/>
           <a:p>
             <a:r>
-              <a:rPr lang="en-US" smtClean="0"/>
+              <a:rPr lang="en-US"/>
               <a:t>Click to edit Master title style</a:t>
             </a:r>
-            <a:endParaRPr lang="en-US"/>
           </a:p>
         </p:txBody>
       </p:sp>
@@ -1211,38 +1218,37 @@
           <a:p>
             <a:pPr lvl="0"/>
             <a:r>
-              <a:rPr lang="en-US" smtClean="0"/>
+              <a:rPr lang="en-US"/>
               <a:t>Click to edit Master text styles</a:t>
             </a:r>
           </a:p>
           <a:p>
             <a:pPr lvl="1"/>
             <a:r>
-              <a:rPr lang="en-US" smtClean="0"/>
+              <a:rPr lang="en-US"/>
               <a:t>Second level</a:t>
             </a:r>
           </a:p>
           <a:p>
             <a:pPr lvl="2"/>
             <a:r>
-              <a:rPr lang="en-US" smtClean="0"/>
+              <a:rPr lang="en-US"/>
               <a:t>Third level</a:t>
             </a:r>
           </a:p>
           <a:p>
             <a:pPr lvl="3"/>
             <a:r>
-              <a:rPr lang="en-US" smtClean="0"/>
+              <a:rPr lang="en-US"/>
               <a:t>Fourth level</a:t>
             </a:r>
           </a:p>
           <a:p>
             <a:pPr lvl="4"/>
             <a:r>
-              <a:rPr lang="en-US" smtClean="0"/>
+              <a:rPr lang="en-US"/>
               <a:t>Fifth level</a:t>
             </a:r>
-            <a:endParaRPr lang="en-US"/>
           </a:p>
         </p:txBody>
       </p:sp>
@@ -1296,38 +1302,37 @@
           <a:p>
             <a:pPr lvl="0"/>
             <a:r>
-              <a:rPr lang="en-US" smtClean="0"/>
+              <a:rPr lang="en-US"/>
               <a:t>Click to edit Master text styles</a:t>
             </a:r>
           </a:p>
           <a:p>
             <a:pPr lvl="1"/>
             <a:r>
-              <a:rPr lang="en-US" smtClean="0"/>
+              <a:rPr lang="en-US"/>
               <a:t>Second level</a:t>
             </a:r>
           </a:p>
           <a:p>
             <a:pPr lvl="2"/>
             <a:r>
-              <a:rPr lang="en-US" smtClean="0"/>
+              <a:rPr lang="en-US"/>
               <a:t>Third level</a:t>
             </a:r>
           </a:p>
           <a:p>
             <a:pPr lvl="3"/>
             <a:r>
-              <a:rPr lang="en-US" smtClean="0"/>
+              <a:rPr lang="en-US"/>
               <a:t>Fourth level</a:t>
             </a:r>
           </a:p>
           <a:p>
             <a:pPr lvl="4"/>
             <a:r>
-              <a:rPr lang="en-US" smtClean="0"/>
+              <a:rPr lang="en-US"/>
               <a:t>Fifth level</a:t>
             </a:r>
-            <a:endParaRPr lang="en-US"/>
           </a:p>
         </p:txBody>
       </p:sp>
@@ -1348,7 +1353,7 @@
           <a:p>
             <a:fld id="{5BCAD085-E8A6-8845-BD4E-CB4CCA059FC4}" type="datetimeFigureOut">
               <a:rPr lang="en-US" smtClean="0"/>
-              <a:t>1/27/13</a:t>
+              <a:t>5/14/2026</a:t>
             </a:fld>
             <a:endParaRPr lang="en-US"/>
           </a:p>
@@ -1446,10 +1451,9 @@
           </a:lstStyle>
           <a:p>
             <a:r>
-              <a:rPr lang="en-US" smtClean="0"/>
+              <a:rPr lang="en-US"/>
               <a:t>Click to edit Master title style</a:t>
             </a:r>
-            <a:endParaRPr lang="en-US"/>
           </a:p>
         </p:txBody>
       </p:sp>
@@ -1512,7 +1516,7 @@
           <a:p>
             <a:pPr lvl="0"/>
             <a:r>
-              <a:rPr lang="en-US" smtClean="0"/>
+              <a:rPr lang="en-US"/>
               <a:t>Click to edit Master text styles</a:t>
             </a:r>
           </a:p>
@@ -1568,38 +1572,37 @@
           <a:p>
             <a:pPr lvl="0"/>
             <a:r>
-              <a:rPr lang="en-US" smtClean="0"/>
+              <a:rPr lang="en-US"/>
               <a:t>Click to edit Master text styles</a:t>
             </a:r>
           </a:p>
           <a:p>
             <a:pPr lvl="1"/>
             <a:r>
-              <a:rPr lang="en-US" smtClean="0"/>
+              <a:rPr lang="en-US"/>
               <a:t>Second level</a:t>
             </a:r>
           </a:p>
           <a:p>
             <a:pPr lvl="2"/>
             <a:r>
-              <a:rPr lang="en-US" smtClean="0"/>
+              <a:rPr lang="en-US"/>
               <a:t>Third level</a:t>
             </a:r>
           </a:p>
           <a:p>
             <a:pPr lvl="3"/>
             <a:r>
-              <a:rPr lang="en-US" smtClean="0"/>
+              <a:rPr lang="en-US"/>
               <a:t>Fourth level</a:t>
             </a:r>
           </a:p>
           <a:p>
             <a:pPr lvl="4"/>
             <a:r>
-              <a:rPr lang="en-US" smtClean="0"/>
+              <a:rPr lang="en-US"/>
               <a:t>Fifth level</a:t>
             </a:r>
-            <a:endParaRPr lang="en-US"/>
           </a:p>
         </p:txBody>
       </p:sp>
@@ -1662,7 +1665,7 @@
           <a:p>
             <a:pPr lvl="0"/>
             <a:r>
-              <a:rPr lang="en-US" smtClean="0"/>
+              <a:rPr lang="en-US"/>
               <a:t>Click to edit Master text styles</a:t>
             </a:r>
           </a:p>
@@ -1718,38 +1721,37 @@
           <a:p>
             <a:pPr lvl="0"/>
             <a:r>
-              <a:rPr lang="en-US" smtClean="0"/>
+              <a:rPr lang="en-US"/>
               <a:t>Click to edit Master text styles</a:t>
             </a:r>
           </a:p>
           <a:p>
             <a:pPr lvl="1"/>
             <a:r>
-              <a:rPr lang="en-US" smtClean="0"/>
+              <a:rPr lang="en-US"/>
               <a:t>Second level</a:t>
             </a:r>
           </a:p>
           <a:p>
             <a:pPr lvl="2"/>
             <a:r>
-              <a:rPr lang="en-US" smtClean="0"/>
+              <a:rPr lang="en-US"/>
               <a:t>Third level</a:t>
             </a:r>
           </a:p>
           <a:p>
             <a:pPr lvl="3"/>
             <a:r>
-              <a:rPr lang="en-US" smtClean="0"/>
+              <a:rPr lang="en-US"/>
               <a:t>Fourth level</a:t>
             </a:r>
           </a:p>
           <a:p>
             <a:pPr lvl="4"/>
             <a:r>
-              <a:rPr lang="en-US" smtClean="0"/>
+              <a:rPr lang="en-US"/>
               <a:t>Fifth level</a:t>
             </a:r>
-            <a:endParaRPr lang="en-US"/>
           </a:p>
         </p:txBody>
       </p:sp>
@@ -1770,7 +1772,7 @@
           <a:p>
             <a:fld id="{5BCAD085-E8A6-8845-BD4E-CB4CCA059FC4}" type="datetimeFigureOut">
               <a:rPr lang="en-US" smtClean="0"/>
-              <a:t>1/27/13</a:t>
+              <a:t>5/14/2026</a:t>
             </a:fld>
             <a:endParaRPr lang="en-US"/>
           </a:p>
@@ -1864,10 +1866,9 @@
           <a:lstStyle/>
           <a:p>
             <a:r>
-              <a:rPr lang="en-US" smtClean="0"/>
+              <a:rPr lang="en-US"/>
               <a:t>Click to edit Master title style</a:t>
             </a:r>
-            <a:endParaRPr lang="en-US"/>
           </a:p>
         </p:txBody>
       </p:sp>
@@ -1888,7 +1889,7 @@
           <a:p>
             <a:fld id="{5BCAD085-E8A6-8845-BD4E-CB4CCA059FC4}" type="datetimeFigureOut">
               <a:rPr lang="en-US" smtClean="0"/>
-              <a:t>1/27/13</a:t>
+              <a:t>5/14/2026</a:t>
             </a:fld>
             <a:endParaRPr lang="en-US"/>
           </a:p>
@@ -1983,7 +1984,7 @@
           <a:p>
             <a:fld id="{5BCAD085-E8A6-8845-BD4E-CB4CCA059FC4}" type="datetimeFigureOut">
               <a:rPr lang="en-US" smtClean="0"/>
-              <a:t>1/27/13</a:t>
+              <a:t>5/14/2026</a:t>
             </a:fld>
             <a:endParaRPr lang="en-US"/>
           </a:p>
@@ -2086,10 +2087,9 @@
           </a:lstStyle>
           <a:p>
             <a:r>
-              <a:rPr lang="en-US" smtClean="0"/>
+              <a:rPr lang="en-US"/>
               <a:t>Click to edit Master title style</a:t>
             </a:r>
-            <a:endParaRPr lang="en-US"/>
           </a:p>
         </p:txBody>
       </p:sp>
@@ -2143,38 +2143,37 @@
           <a:p>
             <a:pPr lvl="0"/>
             <a:r>
-              <a:rPr lang="en-US" smtClean="0"/>
+              <a:rPr lang="en-US"/>
               <a:t>Click to edit Master text styles</a:t>
             </a:r>
           </a:p>
           <a:p>
             <a:pPr lvl="1"/>
             <a:r>
-              <a:rPr lang="en-US" smtClean="0"/>
+              <a:rPr lang="en-US"/>
               <a:t>Second level</a:t>
             </a:r>
           </a:p>
           <a:p>
             <a:pPr lvl="2"/>
             <a:r>
-              <a:rPr lang="en-US" smtClean="0"/>
+              <a:rPr lang="en-US"/>
               <a:t>Third level</a:t>
             </a:r>
           </a:p>
           <a:p>
             <a:pPr lvl="3"/>
             <a:r>
-              <a:rPr lang="en-US" smtClean="0"/>
+              <a:rPr lang="en-US"/>
               <a:t>Fourth level</a:t>
             </a:r>
           </a:p>
           <a:p>
             <a:pPr lvl="4"/>
             <a:r>
-              <a:rPr lang="en-US" smtClean="0"/>
+              <a:rPr lang="en-US"/>
               <a:t>Fifth level</a:t>
             </a:r>
-            <a:endParaRPr lang="en-US"/>
           </a:p>
         </p:txBody>
       </p:sp>
@@ -2237,7 +2236,7 @@
           <a:p>
             <a:pPr lvl="0"/>
             <a:r>
-              <a:rPr lang="en-US" smtClean="0"/>
+              <a:rPr lang="en-US"/>
               <a:t>Click to edit Master text styles</a:t>
             </a:r>
           </a:p>
@@ -2260,7 +2259,7 @@
           <a:p>
             <a:fld id="{5BCAD085-E8A6-8845-BD4E-CB4CCA059FC4}" type="datetimeFigureOut">
               <a:rPr lang="en-US" smtClean="0"/>
-              <a:t>1/27/13</a:t>
+              <a:t>5/14/2026</a:t>
             </a:fld>
             <a:endParaRPr lang="en-US"/>
           </a:p>
@@ -2363,10 +2362,9 @@
           </a:lstStyle>
           <a:p>
             <a:r>
-              <a:rPr lang="en-US" smtClean="0"/>
+              <a:rPr lang="en-US"/>
               <a:t>Click to edit Master title style</a:t>
             </a:r>
-            <a:endParaRPr lang="en-US"/>
           </a:p>
         </p:txBody>
       </p:sp>
@@ -2490,7 +2488,7 @@
           <a:p>
             <a:pPr lvl="0"/>
             <a:r>
-              <a:rPr lang="en-US" smtClean="0"/>
+              <a:rPr lang="en-US"/>
               <a:t>Click to edit Master text styles</a:t>
             </a:r>
           </a:p>
@@ -2513,7 +2511,7 @@
           <a:p>
             <a:fld id="{5BCAD085-E8A6-8845-BD4E-CB4CCA059FC4}" type="datetimeFigureOut">
               <a:rPr lang="en-US" smtClean="0"/>
-              <a:t>1/27/13</a:t>
+              <a:t>5/14/2026</a:t>
             </a:fld>
             <a:endParaRPr lang="en-US"/>
           </a:p>
@@ -2622,10 +2620,9 @@
           <a:lstStyle/>
           <a:p>
             <a:r>
-              <a:rPr lang="en-US" smtClean="0"/>
+              <a:rPr lang="en-US"/>
               <a:t>Click to edit Master title style</a:t>
             </a:r>
-            <a:endParaRPr lang="en-US"/>
           </a:p>
         </p:txBody>
       </p:sp>
@@ -2656,38 +2653,37 @@
           <a:p>
             <a:pPr lvl="0"/>
             <a:r>
-              <a:rPr lang="en-US" smtClean="0"/>
+              <a:rPr lang="en-US"/>
               <a:t>Click to edit Master text styles</a:t>
             </a:r>
           </a:p>
           <a:p>
             <a:pPr lvl="1"/>
             <a:r>
-              <a:rPr lang="en-US" smtClean="0"/>
+              <a:rPr lang="en-US"/>
               <a:t>Second level</a:t>
             </a:r>
           </a:p>
           <a:p>
             <a:pPr lvl="2"/>
             <a:r>
-              <a:rPr lang="en-US" smtClean="0"/>
+              <a:rPr lang="en-US"/>
               <a:t>Third level</a:t>
             </a:r>
           </a:p>
           <a:p>
             <a:pPr lvl="3"/>
             <a:r>
-              <a:rPr lang="en-US" smtClean="0"/>
+              <a:rPr lang="en-US"/>
               <a:t>Fourth level</a:t>
             </a:r>
           </a:p>
           <a:p>
             <a:pPr lvl="4"/>
             <a:r>
-              <a:rPr lang="en-US" smtClean="0"/>
+              <a:rPr lang="en-US"/>
               <a:t>Fifth level</a:t>
             </a:r>
-            <a:endParaRPr lang="en-US"/>
           </a:p>
         </p:txBody>
       </p:sp>
@@ -2726,7 +2722,7 @@
           <a:p>
             <a:fld id="{5BCAD085-E8A6-8845-BD4E-CB4CCA059FC4}" type="datetimeFigureOut">
               <a:rPr lang="en-US" smtClean="0"/>
-              <a:t>1/27/13</a:t>
+              <a:t>5/14/2026</a:t>
             </a:fld>
             <a:endParaRPr lang="en-US"/>
           </a:p>
@@ -3085,7 +3081,7 @@
 </file>
 
 <file path=ppt/slides/slide1.xml><?xml version="1.0" encoding="utf-8"?>
-<p:sld xmlns:a="http://schemas.openxmlformats.org/drawingml/2006/main" xmlns:p="http://schemas.openxmlformats.org/presentationml/2006/main" xmlns:r="http://schemas.openxmlformats.org/officeDocument/2006/relationships">
+<p:sld xmlns:a="http://schemas.openxmlformats.org/drawingml/2006/main" xmlns:r="http://schemas.openxmlformats.org/officeDocument/2006/relationships" xmlns:p="http://schemas.openxmlformats.org/presentationml/2006/main">
   <p:cSld>
     <p:spTree>
       <p:nvGrpSpPr>
@@ -3093,7 +3089,14 @@
         <p:cNvGrpSpPr/>
         <p:nvPr/>
       </p:nvGrpSpPr>
-      <p:grpSpPr/>
+      <p:grpSpPr>
+        <a:xfrm>
+          <a:off x="0" y="0"/>
+          <a:ext cx="0" cy="0"/>
+          <a:chOff x="0" y="0"/>
+          <a:chExt cx="0" cy="0"/>
+        </a:xfrm>
+      </p:grpSpPr>
       <p:sp>
         <p:nvSpPr>
           <p:cNvPr id="2" name="Rectangle 1"/>
@@ -3134,6 +3137,7 @@
           <a:lstStyle/>
           <a:p>
             <a:pPr algn="ctr"/>
+            <a:endParaRPr/>
           </a:p>
         </p:txBody>
       </p:sp>
@@ -3177,6 +3181,7 @@
           <a:lstStyle/>
           <a:p>
             <a:pPr algn="ctr"/>
+            <a:endParaRPr/>
           </a:p>
         </p:txBody>
       </p:sp>
@@ -3257,7 +3262,7 @@
 </file>
 
 <file path=ppt/slides/slide2.xml><?xml version="1.0" encoding="utf-8"?>
-<p:sld xmlns:a="http://schemas.openxmlformats.org/drawingml/2006/main" xmlns:p="http://schemas.openxmlformats.org/presentationml/2006/main" xmlns:r="http://schemas.openxmlformats.org/officeDocument/2006/relationships">
+<p:sld xmlns:a="http://schemas.openxmlformats.org/drawingml/2006/main" xmlns:r="http://schemas.openxmlformats.org/officeDocument/2006/relationships" xmlns:p="http://schemas.openxmlformats.org/presentationml/2006/main">
   <p:cSld>
     <p:spTree>
       <p:nvGrpSpPr>
@@ -3265,7 +3270,14 @@
         <p:cNvGrpSpPr/>
         <p:nvPr/>
       </p:nvGrpSpPr>
-      <p:grpSpPr/>
+      <p:grpSpPr>
+        <a:xfrm>
+          <a:off x="0" y="0"/>
+          <a:ext cx="0" cy="0"/>
+          <a:chOff x="0" y="0"/>
+          <a:chExt cx="0" cy="0"/>
+        </a:xfrm>
+      </p:grpSpPr>
       <p:sp>
         <p:nvSpPr>
           <p:cNvPr id="2" name="Rectangle 1"/>
@@ -3306,6 +3318,7 @@
           <a:lstStyle/>
           <a:p>
             <a:pPr algn="ctr"/>
+            <a:endParaRPr/>
           </a:p>
         </p:txBody>
       </p:sp>
@@ -3354,7 +3367,7 @@
         <p:spPr>
           <a:xfrm>
             <a:off x="548640" y="1280160"/>
-            <a:ext cx="8046720" cy="3291840"/>
+            <a:ext cx="8046720" cy="738664"/>
           </a:xfrm>
           <a:prstGeom prst="rect">
             <a:avLst/>
@@ -3379,10 +3392,11 @@
               </a:defRPr>
             </a:pPr>
             <a:r>
+              <a:rPr dirty="0"/>
               <a:t>•  The Scale Principle: </a:t>
             </a:r>
             <a:r>
-              <a:rPr b="0">
+              <a:rPr b="0" dirty="0">
                 <a:solidFill>
                   <a:srgbClr val="0F172A"/>
                 </a:solidFill>
@@ -3390,62 +3404,38 @@
               <a:t>An equation is an exactly balanced scale. The values on both sides of the equals sign MUST represent the identical total.</a:t>
             </a:r>
           </a:p>
-          <a:p>
-            <a:pPr>
-              <a:spcBef>
-                <a:spcPts val="1400"/>
-              </a:spcBef>
-              <a:spcAft>
-                <a:spcPts val="400"/>
-              </a:spcAft>
-              <a:defRPr sz="1800" b="1">
-                <a:solidFill>
-                  <a:srgbClr val="14B8A6"/>
-                </a:solidFill>
-                <a:latin typeface="Arial"/>
-              </a:defRPr>
-            </a:pPr>
-            <a:r>
-              <a:t>•  Addition ↔ Subtraction: </a:t>
-            </a:r>
-            <a:r>
-              <a:rPr b="0">
-                <a:solidFill>
-                  <a:srgbClr val="0F172A"/>
-                </a:solidFill>
-              </a:rPr>
-              <a:t>They are inverse operations (exact opposites). If a missing number sentence adds a value, subtract it from the total to work backwards!</a:t>
-            </a:r>
-          </a:p>
-          <a:p>
-            <a:pPr>
-              <a:spcBef>
-                <a:spcPts val="1400"/>
-              </a:spcBef>
-              <a:spcAft>
-                <a:spcPts val="400"/>
-              </a:spcAft>
-              <a:defRPr sz="1800" b="1">
-                <a:solidFill>
-                  <a:srgbClr val="14B8A6"/>
-                </a:solidFill>
-                <a:latin typeface="Arial"/>
-              </a:defRPr>
-            </a:pPr>
-            <a:r>
-              <a:t>•  Multiplication ↔ Division: </a:t>
-            </a:r>
-            <a:r>
-              <a:rPr b="0">
-                <a:solidFill>
-                  <a:srgbClr val="0F172A"/>
-                </a:solidFill>
-              </a:rPr>
-              <a:t>They form closely linked fact families. Use known multiplication facts to rapidly uncover unknown division components.</a:t>
-            </a:r>
-          </a:p>
-        </p:txBody>
-      </p:sp>
+        </p:txBody>
+      </p:sp>
+      <p:pic>
+        <p:nvPicPr>
+          <p:cNvPr id="8" name="Picture 7">
+            <a:extLst>
+              <a:ext uri="{FF2B5EF4-FFF2-40B4-BE49-F238E27FC236}">
+                <a16:creationId xmlns:a16="http://schemas.microsoft.com/office/drawing/2014/main" id="{999A239B-36CB-5BC8-F4F3-CD58C4403297}"/>
+              </a:ext>
+            </a:extLst>
+          </p:cNvPr>
+          <p:cNvPicPr>
+            <a:picLocks noChangeAspect="1"/>
+          </p:cNvPicPr>
+          <p:nvPr/>
+        </p:nvPicPr>
+        <p:blipFill>
+          <a:blip r:embed="rId2"/>
+          <a:stretch>
+            <a:fillRect/>
+          </a:stretch>
+        </p:blipFill>
+        <p:spPr>
+          <a:xfrm>
+            <a:off x="1909678" y="2018824"/>
+            <a:ext cx="5324643" cy="2996704"/>
+          </a:xfrm>
+          <a:prstGeom prst="rect">
+            <a:avLst/>
+          </a:prstGeom>
+        </p:spPr>
+      </p:pic>
     </p:spTree>
   </p:cSld>
   <p:clrMapOvr>
@@ -3455,18 +3445,37 @@
 </file>
 
 <file path=ppt/slides/slide3.xml><?xml version="1.0" encoding="utf-8"?>
-<p:sld xmlns:a="http://schemas.openxmlformats.org/drawingml/2006/main" xmlns:p="http://schemas.openxmlformats.org/presentationml/2006/main" xmlns:r="http://schemas.openxmlformats.org/officeDocument/2006/relationships">
+<p:sld xmlns:a="http://schemas.openxmlformats.org/drawingml/2006/main" xmlns:r="http://schemas.openxmlformats.org/officeDocument/2006/relationships" xmlns:p="http://schemas.openxmlformats.org/presentationml/2006/main">
   <p:cSld>
     <p:spTree>
       <p:nvGrpSpPr>
-        <p:cNvPr id="1" name=""/>
+        <p:cNvPr id="1" name="">
+          <a:extLst>
+            <a:ext uri="{FF2B5EF4-FFF2-40B4-BE49-F238E27FC236}">
+              <a16:creationId xmlns:a16="http://schemas.microsoft.com/office/drawing/2014/main" id="{4EA184A9-DAB5-B701-D666-CA1566ADEB9A}"/>
+            </a:ext>
+          </a:extLst>
+        </p:cNvPr>
         <p:cNvGrpSpPr/>
         <p:nvPr/>
       </p:nvGrpSpPr>
-      <p:grpSpPr/>
-      <p:sp>
-        <p:nvSpPr>
-          <p:cNvPr id="2" name="Rectangle 1"/>
+      <p:grpSpPr>
+        <a:xfrm>
+          <a:off x="0" y="0"/>
+          <a:ext cx="0" cy="0"/>
+          <a:chOff x="0" y="0"/>
+          <a:chExt cx="0" cy="0"/>
+        </a:xfrm>
+      </p:grpSpPr>
+      <p:sp>
+        <p:nvSpPr>
+          <p:cNvPr id="2" name="Rectangle 1">
+            <a:extLst>
+              <a:ext uri="{FF2B5EF4-FFF2-40B4-BE49-F238E27FC236}">
+                <a16:creationId xmlns:a16="http://schemas.microsoft.com/office/drawing/2014/main" id="{14DDDF4A-7EA8-63E1-B4D2-B16041FFB4C9}"/>
+              </a:ext>
+            </a:extLst>
+          </p:cNvPr>
           <p:cNvSpPr/>
           <p:nvPr/>
         </p:nvSpPr>
@@ -3504,6 +3513,208 @@
           <a:lstStyle/>
           <a:p>
             <a:pPr algn="ctr"/>
+            <a:endParaRPr/>
+          </a:p>
+        </p:txBody>
+      </p:sp>
+      <p:sp>
+        <p:nvSpPr>
+          <p:cNvPr id="3" name="TextBox 2">
+            <a:extLst>
+              <a:ext uri="{FF2B5EF4-FFF2-40B4-BE49-F238E27FC236}">
+                <a16:creationId xmlns:a16="http://schemas.microsoft.com/office/drawing/2014/main" id="{E5D947B5-71B7-1CB1-29C8-394F644051E7}"/>
+              </a:ext>
+            </a:extLst>
+          </p:cNvPr>
+          <p:cNvSpPr txBox="1"/>
+          <p:nvPr/>
+        </p:nvSpPr>
+        <p:spPr>
+          <a:xfrm>
+            <a:off x="548640" y="365760"/>
+            <a:ext cx="8046720" cy="731520"/>
+          </a:xfrm>
+          <a:prstGeom prst="rect">
+            <a:avLst/>
+          </a:prstGeom>
+          <a:noFill/>
+        </p:spPr>
+        <p:txBody>
+          <a:bodyPr wrap="square" tIns="91440" bIns="91440">
+            <a:spAutoFit/>
+          </a:bodyPr>
+          <a:lstStyle/>
+          <a:p>
+            <a:pPr>
+              <a:defRPr sz="2800" b="1">
+                <a:solidFill>
+                  <a:srgbClr val="0F172A"/>
+                </a:solidFill>
+                <a:latin typeface="Arial"/>
+              </a:defRPr>
+            </a:pPr>
+            <a:r>
+              <a:t>The Golden Rules of Balancing</a:t>
+            </a:r>
+          </a:p>
+        </p:txBody>
+      </p:sp>
+      <p:sp>
+        <p:nvSpPr>
+          <p:cNvPr id="4" name="TextBox 3">
+            <a:extLst>
+              <a:ext uri="{FF2B5EF4-FFF2-40B4-BE49-F238E27FC236}">
+                <a16:creationId xmlns:a16="http://schemas.microsoft.com/office/drawing/2014/main" id="{94C8A1B7-F4CB-FC80-2476-3FC3994945DE}"/>
+              </a:ext>
+            </a:extLst>
+          </p:cNvPr>
+          <p:cNvSpPr txBox="1"/>
+          <p:nvPr/>
+        </p:nvSpPr>
+        <p:spPr>
+          <a:xfrm>
+            <a:off x="548640" y="1280160"/>
+            <a:ext cx="8046720" cy="1800493"/>
+          </a:xfrm>
+          <a:prstGeom prst="rect">
+            <a:avLst/>
+          </a:prstGeom>
+          <a:noFill/>
+        </p:spPr>
+        <p:txBody>
+          <a:bodyPr wrap="square" tIns="91440" bIns="91440">
+            <a:spAutoFit/>
+          </a:bodyPr>
+          <a:lstStyle/>
+          <a:p>
+            <a:pPr>
+              <a:spcBef>
+                <a:spcPts val="1400"/>
+              </a:spcBef>
+              <a:spcAft>
+                <a:spcPts val="400"/>
+              </a:spcAft>
+              <a:defRPr sz="1800" b="1">
+                <a:solidFill>
+                  <a:srgbClr val="14B8A6"/>
+                </a:solidFill>
+                <a:latin typeface="Arial"/>
+              </a:defRPr>
+            </a:pPr>
+            <a:r>
+              <a:rPr dirty="0"/>
+              <a:t>•  Addition ↔ Subtraction: </a:t>
+            </a:r>
+            <a:r>
+              <a:rPr b="0" dirty="0">
+                <a:solidFill>
+                  <a:srgbClr val="0F172A"/>
+                </a:solidFill>
+              </a:rPr>
+              <a:t>They are inverse operations (exact opposites). If a missing number sentence adds a value, subtract it from the total to work backwards!</a:t>
+            </a:r>
+          </a:p>
+          <a:p>
+            <a:pPr>
+              <a:spcBef>
+                <a:spcPts val="1400"/>
+              </a:spcBef>
+              <a:spcAft>
+                <a:spcPts val="400"/>
+              </a:spcAft>
+              <a:defRPr sz="1800" b="1">
+                <a:solidFill>
+                  <a:srgbClr val="14B8A6"/>
+                </a:solidFill>
+                <a:latin typeface="Arial"/>
+              </a:defRPr>
+            </a:pPr>
+            <a:r>
+              <a:rPr dirty="0"/>
+              <a:t>•  Multiplication ↔ Division: </a:t>
+            </a:r>
+            <a:r>
+              <a:rPr b="0" dirty="0">
+                <a:solidFill>
+                  <a:srgbClr val="0F172A"/>
+                </a:solidFill>
+              </a:rPr>
+              <a:t>They form closely linked fact families. Use known multiplication facts to rapidly uncover unknown division components.</a:t>
+            </a:r>
+          </a:p>
+        </p:txBody>
+      </p:sp>
+    </p:spTree>
+    <p:extLst>
+      <p:ext uri="{BB962C8B-B14F-4D97-AF65-F5344CB8AC3E}">
+        <p14:creationId xmlns:p14="http://schemas.microsoft.com/office/powerpoint/2010/main" val="1231468214"/>
+      </p:ext>
+    </p:extLst>
+  </p:cSld>
+  <p:clrMapOvr>
+    <a:masterClrMapping/>
+  </p:clrMapOvr>
+</p:sld>
+</file>
+
+<file path=ppt/slides/slide4.xml><?xml version="1.0" encoding="utf-8"?>
+<p:sld xmlns:a="http://schemas.openxmlformats.org/drawingml/2006/main" xmlns:r="http://schemas.openxmlformats.org/officeDocument/2006/relationships" xmlns:p="http://schemas.openxmlformats.org/presentationml/2006/main">
+  <p:cSld>
+    <p:spTree>
+      <p:nvGrpSpPr>
+        <p:cNvPr id="1" name=""/>
+        <p:cNvGrpSpPr/>
+        <p:nvPr/>
+      </p:nvGrpSpPr>
+      <p:grpSpPr>
+        <a:xfrm>
+          <a:off x="0" y="0"/>
+          <a:ext cx="0" cy="0"/>
+          <a:chOff x="0" y="0"/>
+          <a:chExt cx="0" cy="0"/>
+        </a:xfrm>
+      </p:grpSpPr>
+      <p:sp>
+        <p:nvSpPr>
+          <p:cNvPr id="2" name="Rectangle 1"/>
+          <p:cNvSpPr/>
+          <p:nvPr/>
+        </p:nvSpPr>
+        <p:spPr>
+          <a:xfrm>
+            <a:off x="0" y="0"/>
+            <a:ext cx="9144000" cy="5143500"/>
+          </a:xfrm>
+          <a:prstGeom prst="rect">
+            <a:avLst/>
+          </a:prstGeom>
+          <a:solidFill>
+            <a:srgbClr val="F8FAFC"/>
+          </a:solidFill>
+          <a:ln>
+            <a:noFill/>
+          </a:ln>
+        </p:spPr>
+        <p:style>
+          <a:lnRef idx="1">
+            <a:schemeClr val="accent1"/>
+          </a:lnRef>
+          <a:fillRef idx="3">
+            <a:schemeClr val="accent1"/>
+          </a:fillRef>
+          <a:effectRef idx="2">
+            <a:schemeClr val="accent1"/>
+          </a:effectRef>
+          <a:fontRef idx="minor">
+            <a:schemeClr val="lt1"/>
+          </a:fontRef>
+        </p:style>
+        <p:txBody>
+          <a:bodyPr rtlCol="0" anchor="ctr"/>
+          <a:lstStyle/>
+          <a:p>
+            <a:pPr algn="ctr"/>
+            <a:endParaRPr/>
           </a:p>
         </p:txBody>
       </p:sp>
@@ -3581,7 +3792,7 @@
           </a:fontRef>
         </p:style>
         <p:txBody>
-          <a:bodyPr rtlCol="0" anchor="t" wrap="square" tIns="91440" bIns="91440"/>
+          <a:bodyPr wrap="square" tIns="91440" bIns="91440" rtlCol="0" anchor="t"/>
           <a:lstStyle/>
           <a:p>
             <a:pPr algn="ctr">
@@ -3677,7 +3888,7 @@
           </a:fontRef>
         </p:style>
         <p:txBody>
-          <a:bodyPr rtlCol="0" anchor="t" wrap="square" tIns="91440" bIns="91440"/>
+          <a:bodyPr wrap="square" tIns="91440" bIns="91440" rtlCol="0" anchor="t"/>
           <a:lstStyle/>
           <a:p>
             <a:pPr algn="ctr">
@@ -3773,7 +3984,7 @@
           </a:fontRef>
         </p:style>
         <p:txBody>
-          <a:bodyPr rtlCol="0" anchor="t" wrap="square" tIns="91440" bIns="91440"/>
+          <a:bodyPr wrap="square" tIns="91440" bIns="91440" rtlCol="0" anchor="t"/>
           <a:lstStyle/>
           <a:p>
             <a:pPr algn="ctr">
@@ -3839,8 +4050,8 @@
 </p:sld>
 </file>
 
-<file path=ppt/slides/slide4.xml><?xml version="1.0" encoding="utf-8"?>
-<p:sld xmlns:a="http://schemas.openxmlformats.org/drawingml/2006/main" xmlns:p="http://schemas.openxmlformats.org/presentationml/2006/main" xmlns:r="http://schemas.openxmlformats.org/officeDocument/2006/relationships">
+<file path=ppt/slides/slide5.xml><?xml version="1.0" encoding="utf-8"?>
+<p:sld xmlns:a="http://schemas.openxmlformats.org/drawingml/2006/main" xmlns:r="http://schemas.openxmlformats.org/officeDocument/2006/relationships" xmlns:p="http://schemas.openxmlformats.org/presentationml/2006/main">
   <p:cSld>
     <p:spTree>
       <p:nvGrpSpPr>
@@ -3848,7 +4059,14 @@
         <p:cNvGrpSpPr/>
         <p:nvPr/>
       </p:nvGrpSpPr>
-      <p:grpSpPr/>
+      <p:grpSpPr>
+        <a:xfrm>
+          <a:off x="0" y="0"/>
+          <a:ext cx="0" cy="0"/>
+          <a:chOff x="0" y="0"/>
+          <a:chExt cx="0" cy="0"/>
+        </a:xfrm>
+      </p:grpSpPr>
       <p:sp>
         <p:nvSpPr>
           <p:cNvPr id="2" name="Rectangle 1"/>
@@ -3889,6 +4107,7 @@
           <a:lstStyle/>
           <a:p>
             <a:pPr algn="ctr"/>
+            <a:endParaRPr/>
           </a:p>
         </p:txBody>
       </p:sp>
@@ -3966,7 +4185,7 @@
           </a:fontRef>
         </p:style>
         <p:txBody>
-          <a:bodyPr rtlCol="0" anchor="t" wrap="square" tIns="91440" bIns="91440"/>
+          <a:bodyPr wrap="square" tIns="91440" bIns="91440" rtlCol="0" anchor="t"/>
           <a:lstStyle/>
           <a:p>
             <a:pPr algn="ctr">
@@ -4066,7 +4285,7 @@
           </a:fontRef>
         </p:style>
         <p:txBody>
-          <a:bodyPr rtlCol="0" anchor="t" wrap="square" tIns="91440" bIns="91440"/>
+          <a:bodyPr wrap="square" tIns="91440" bIns="91440" rtlCol="0" anchor="t"/>
           <a:lstStyle/>
           <a:p>
             <a:pPr algn="ctr">
@@ -4140,8 +4359,8 @@
 </p:sld>
 </file>
 
-<file path=ppt/slides/slide5.xml><?xml version="1.0" encoding="utf-8"?>
-<p:sld xmlns:a="http://schemas.openxmlformats.org/drawingml/2006/main" xmlns:p="http://schemas.openxmlformats.org/presentationml/2006/main" xmlns:r="http://schemas.openxmlformats.org/officeDocument/2006/relationships">
+<file path=ppt/slides/slide6.xml><?xml version="1.0" encoding="utf-8"?>
+<p:sld xmlns:a="http://schemas.openxmlformats.org/drawingml/2006/main" xmlns:r="http://schemas.openxmlformats.org/officeDocument/2006/relationships" xmlns:p="http://schemas.openxmlformats.org/presentationml/2006/main">
   <p:cSld>
     <p:spTree>
       <p:nvGrpSpPr>
@@ -4149,7 +4368,14 @@
         <p:cNvGrpSpPr/>
         <p:nvPr/>
       </p:nvGrpSpPr>
-      <p:grpSpPr/>
+      <p:grpSpPr>
+        <a:xfrm>
+          <a:off x="0" y="0"/>
+          <a:ext cx="0" cy="0"/>
+          <a:chOff x="0" y="0"/>
+          <a:chExt cx="0" cy="0"/>
+        </a:xfrm>
+      </p:grpSpPr>
       <p:sp>
         <p:nvSpPr>
           <p:cNvPr id="2" name="Rectangle 1"/>
@@ -4190,6 +4416,7 @@
           <a:lstStyle/>
           <a:p>
             <a:pPr algn="ctr"/>
+            <a:endParaRPr/>
           </a:p>
         </p:txBody>
       </p:sp>
@@ -4332,7 +4559,7 @@
           </a:fontRef>
         </p:style>
         <p:txBody>
-          <a:bodyPr rtlCol="0" anchor="ctr" wrap="square" tIns="91440" bIns="91440"/>
+          <a:bodyPr wrap="square" tIns="91440" bIns="91440" rtlCol="0" anchor="ctr"/>
           <a:lstStyle/>
           <a:p>
             <a:pPr algn="l">
@@ -4347,7 +4574,7 @@
               <a:t>Target Sentence:  </a:t>
             </a:r>
             <a:r>
-              <a:rPr b="1" sz="1700">
+              <a:rPr sz="1700" b="1">
                 <a:solidFill>
                   <a:srgbClr val="14B8A6"/>
                 </a:solidFill>
@@ -4371,7 +4598,7 @@
               <a:t>Step 1 (Combine):  </a:t>
             </a:r>
             <a:r>
-              <a:rPr b="1" sz="1600">
+              <a:rPr sz="1600" b="1">
                 <a:solidFill>
                   <a:srgbClr val="0F172A"/>
                 </a:solidFill>
@@ -4395,7 +4622,7 @@
               <a:t>Step 2 (Inverse):  </a:t>
             </a:r>
             <a:r>
-              <a:rPr b="1" sz="1600">
+              <a:rPr sz="1600" b="1">
                 <a:solidFill>
                   <a:srgbClr val="0F172A"/>
                 </a:solidFill>
@@ -4419,7 +4646,7 @@
               <a:t>Final Answer:  </a:t>
             </a:r>
             <a:r>
-              <a:rPr b="1" sz="1700">
+              <a:rPr sz="1700" b="1">
                 <a:solidFill>
                   <a:srgbClr val="14B8A6"/>
                 </a:solidFill>
@@ -4437,8 +4664,8 @@
 </p:sld>
 </file>
 
-<file path=ppt/slides/slide6.xml><?xml version="1.0" encoding="utf-8"?>
-<p:sld xmlns:a="http://schemas.openxmlformats.org/drawingml/2006/main" xmlns:p="http://schemas.openxmlformats.org/presentationml/2006/main" xmlns:r="http://schemas.openxmlformats.org/officeDocument/2006/relationships">
+<file path=ppt/slides/slide7.xml><?xml version="1.0" encoding="utf-8"?>
+<p:sld xmlns:a="http://schemas.openxmlformats.org/drawingml/2006/main" xmlns:r="http://schemas.openxmlformats.org/officeDocument/2006/relationships" xmlns:p="http://schemas.openxmlformats.org/presentationml/2006/main">
   <p:cSld>
     <p:spTree>
       <p:nvGrpSpPr>
@@ -4446,7 +4673,14 @@
         <p:cNvGrpSpPr/>
         <p:nvPr/>
       </p:nvGrpSpPr>
-      <p:grpSpPr/>
+      <p:grpSpPr>
+        <a:xfrm>
+          <a:off x="0" y="0"/>
+          <a:ext cx="0" cy="0"/>
+          <a:chOff x="0" y="0"/>
+          <a:chExt cx="0" cy="0"/>
+        </a:xfrm>
+      </p:grpSpPr>
       <p:sp>
         <p:nvSpPr>
           <p:cNvPr id="2" name="Rectangle 1"/>
@@ -4487,6 +4721,7 @@
           <a:lstStyle/>
           <a:p>
             <a:pPr algn="ctr"/>
+            <a:endParaRPr/>
           </a:p>
         </p:txBody>
       </p:sp>
@@ -4564,7 +4799,7 @@
           </a:fontRef>
         </p:style>
         <p:txBody>
-          <a:bodyPr rtlCol="0" anchor="t" wrap="square" tIns="91440" bIns="91440"/>
+          <a:bodyPr wrap="square" tIns="91440" bIns="91440" rtlCol="0" anchor="t"/>
           <a:lstStyle/>
           <a:p>
             <a:pPr algn="ctr">
@@ -4634,8 +4869,8 @@
 </p:sld>
 </file>
 
-<file path=ppt/slides/slide7.xml><?xml version="1.0" encoding="utf-8"?>
-<p:sld xmlns:a="http://schemas.openxmlformats.org/drawingml/2006/main" xmlns:p="http://schemas.openxmlformats.org/presentationml/2006/main" xmlns:r="http://schemas.openxmlformats.org/officeDocument/2006/relationships">
+<file path=ppt/slides/slide8.xml><?xml version="1.0" encoding="utf-8"?>
+<p:sld xmlns:a="http://schemas.openxmlformats.org/drawingml/2006/main" xmlns:r="http://schemas.openxmlformats.org/officeDocument/2006/relationships" xmlns:p="http://schemas.openxmlformats.org/presentationml/2006/main">
   <p:cSld>
     <p:spTree>
       <p:nvGrpSpPr>
@@ -4643,7 +4878,14 @@
         <p:cNvGrpSpPr/>
         <p:nvPr/>
       </p:nvGrpSpPr>
-      <p:grpSpPr/>
+      <p:grpSpPr>
+        <a:xfrm>
+          <a:off x="0" y="0"/>
+          <a:ext cx="0" cy="0"/>
+          <a:chOff x="0" y="0"/>
+          <a:chExt cx="0" cy="0"/>
+        </a:xfrm>
+      </p:grpSpPr>
       <p:sp>
         <p:nvSpPr>
           <p:cNvPr id="2" name="Rectangle 1"/>
@@ -4684,6 +4926,7 @@
           <a:lstStyle/>
           <a:p>
             <a:pPr algn="ctr"/>
+            <a:endParaRPr/>
           </a:p>
         </p:txBody>
       </p:sp>
@@ -4727,6 +4970,7 @@
           <a:lstStyle/>
           <a:p>
             <a:pPr algn="ctr"/>
+            <a:endParaRPr/>
           </a:p>
         </p:txBody>
       </p:sp>

</xml_diff>